<commit_message>
Rebuild H2 research GUI and fix baseline study submission
</commit_message>
<xml_diff>
--- a/Systemgrenzen der Forschungsarbeit.pptx
+++ b/Systemgrenzen der Forschungsarbeit.pptx
@@ -9,6 +9,7 @@
     <p:sldId id="257" r:id="rId3"/>
     <p:sldId id="258" r:id="rId4"/>
     <p:sldId id="259" r:id="rId5"/>
+    <p:sldId id="260" r:id="rId6"/>
   </p:sldIdLst>
   <p:sldSz cx="12192000" cy="6858000"/>
   <p:notesSz cx="6858000" cy="9144000"/>
@@ -262,7 +263,7 @@
           <a:p>
             <a:fld id="{51CED076-D522-43C9-A58C-F6D631DD9FC1}" type="datetimeFigureOut">
               <a:rPr lang="de-DE" smtClean="0"/>
-              <a:t>15.09.2026</a:t>
+              <a:t>13.10.2026</a:t>
             </a:fld>
             <a:endParaRPr lang="de-DE"/>
           </a:p>
@@ -460,7 +461,7 @@
           <a:p>
             <a:fld id="{51CED076-D522-43C9-A58C-F6D631DD9FC1}" type="datetimeFigureOut">
               <a:rPr lang="de-DE" smtClean="0"/>
-              <a:t>15.09.2026</a:t>
+              <a:t>13.10.2026</a:t>
             </a:fld>
             <a:endParaRPr lang="de-DE"/>
           </a:p>
@@ -668,7 +669,7 @@
           <a:p>
             <a:fld id="{51CED076-D522-43C9-A58C-F6D631DD9FC1}" type="datetimeFigureOut">
               <a:rPr lang="de-DE" smtClean="0"/>
-              <a:t>15.09.2026</a:t>
+              <a:t>13.10.2026</a:t>
             </a:fld>
             <a:endParaRPr lang="de-DE"/>
           </a:p>
@@ -866,7 +867,7 @@
           <a:p>
             <a:fld id="{51CED076-D522-43C9-A58C-F6D631DD9FC1}" type="datetimeFigureOut">
               <a:rPr lang="de-DE" smtClean="0"/>
-              <a:t>15.09.2026</a:t>
+              <a:t>13.10.2026</a:t>
             </a:fld>
             <a:endParaRPr lang="de-DE"/>
           </a:p>
@@ -1141,7 +1142,7 @@
           <a:p>
             <a:fld id="{51CED076-D522-43C9-A58C-F6D631DD9FC1}" type="datetimeFigureOut">
               <a:rPr lang="de-DE" smtClean="0"/>
-              <a:t>15.09.2026</a:t>
+              <a:t>13.10.2026</a:t>
             </a:fld>
             <a:endParaRPr lang="de-DE"/>
           </a:p>
@@ -1406,7 +1407,7 @@
           <a:p>
             <a:fld id="{51CED076-D522-43C9-A58C-F6D631DD9FC1}" type="datetimeFigureOut">
               <a:rPr lang="de-DE" smtClean="0"/>
-              <a:t>15.09.2026</a:t>
+              <a:t>13.10.2026</a:t>
             </a:fld>
             <a:endParaRPr lang="de-DE"/>
           </a:p>
@@ -1818,7 +1819,7 @@
           <a:p>
             <a:fld id="{51CED076-D522-43C9-A58C-F6D631DD9FC1}" type="datetimeFigureOut">
               <a:rPr lang="de-DE" smtClean="0"/>
-              <a:t>15.09.2026</a:t>
+              <a:t>13.10.2026</a:t>
             </a:fld>
             <a:endParaRPr lang="de-DE"/>
           </a:p>
@@ -1959,7 +1960,7 @@
           <a:p>
             <a:fld id="{51CED076-D522-43C9-A58C-F6D631DD9FC1}" type="datetimeFigureOut">
               <a:rPr lang="de-DE" smtClean="0"/>
-              <a:t>15.09.2026</a:t>
+              <a:t>13.10.2026</a:t>
             </a:fld>
             <a:endParaRPr lang="de-DE"/>
           </a:p>
@@ -2072,7 +2073,7 @@
           <a:p>
             <a:fld id="{51CED076-D522-43C9-A58C-F6D631DD9FC1}" type="datetimeFigureOut">
               <a:rPr lang="de-DE" smtClean="0"/>
-              <a:t>15.09.2026</a:t>
+              <a:t>13.10.2026</a:t>
             </a:fld>
             <a:endParaRPr lang="de-DE"/>
           </a:p>
@@ -2383,7 +2384,7 @@
           <a:p>
             <a:fld id="{51CED076-D522-43C9-A58C-F6D631DD9FC1}" type="datetimeFigureOut">
               <a:rPr lang="de-DE" smtClean="0"/>
-              <a:t>15.09.2026</a:t>
+              <a:t>13.10.2026</a:t>
             </a:fld>
             <a:endParaRPr lang="de-DE"/>
           </a:p>
@@ -2671,7 +2672,7 @@
           <a:p>
             <a:fld id="{51CED076-D522-43C9-A58C-F6D631DD9FC1}" type="datetimeFigureOut">
               <a:rPr lang="de-DE" smtClean="0"/>
-              <a:t>15.09.2026</a:t>
+              <a:t>13.10.2026</a:t>
             </a:fld>
             <a:endParaRPr lang="de-DE"/>
           </a:p>
@@ -2912,7 +2913,7 @@
           <a:p>
             <a:fld id="{51CED076-D522-43C9-A58C-F6D631DD9FC1}" type="datetimeFigureOut">
               <a:rPr lang="de-DE" smtClean="0"/>
-              <a:t>15.09.2026</a:t>
+              <a:t>13.10.2026</a:t>
             </a:fld>
             <a:endParaRPr lang="de-DE"/>
           </a:p>
@@ -6452,6 +6453,172 @@
     <p:extLst>
       <p:ext uri="{BB962C8B-B14F-4D97-AF65-F5344CB8AC3E}">
         <p14:creationId xmlns:p14="http://schemas.microsoft.com/office/powerpoint/2010/main" val="513017130"/>
+      </p:ext>
+    </p:extLst>
+  </p:cSld>
+  <p:clrMapOvr>
+    <a:masterClrMapping/>
+  </p:clrMapOvr>
+</p:sld>
+</file>
+
+<file path=ppt/slides/slide5.xml><?xml version="1.0" encoding="utf-8"?>
+<p:sld xmlns:a="http://schemas.openxmlformats.org/drawingml/2006/main" xmlns:r="http://schemas.openxmlformats.org/officeDocument/2006/relationships" xmlns:p="http://schemas.openxmlformats.org/presentationml/2006/main">
+  <p:cSld>
+    <p:spTree>
+      <p:nvGrpSpPr>
+        <p:cNvPr id="1" name=""/>
+        <p:cNvGrpSpPr/>
+        <p:nvPr/>
+      </p:nvGrpSpPr>
+      <p:grpSpPr>
+        <a:xfrm>
+          <a:off x="0" y="0"/>
+          <a:ext cx="0" cy="0"/>
+          <a:chOff x="0" y="0"/>
+          <a:chExt cx="0" cy="0"/>
+        </a:xfrm>
+      </p:grpSpPr>
+      <p:sp>
+        <p:nvSpPr>
+          <p:cNvPr id="2" name="Titel 1">
+            <a:extLst>
+              <a:ext uri="{FF2B5EF4-FFF2-40B4-BE49-F238E27FC236}">
+                <a16:creationId xmlns:a16="http://schemas.microsoft.com/office/drawing/2014/main" id="{1EE52B8E-B9D9-A52C-98E2-74C90DD2EA85}"/>
+              </a:ext>
+            </a:extLst>
+          </p:cNvPr>
+          <p:cNvSpPr>
+            <a:spLocks noGrp="1"/>
+          </p:cNvSpPr>
+          <p:nvPr>
+            <p:ph type="title"/>
+          </p:nvPr>
+        </p:nvSpPr>
+        <p:spPr/>
+        <p:txBody>
+          <a:bodyPr/>
+          <a:lstStyle/>
+          <a:p>
+            <a:endParaRPr lang="de-DE"/>
+          </a:p>
+        </p:txBody>
+      </p:sp>
+      <p:sp>
+        <p:nvSpPr>
+          <p:cNvPr id="3" name="Inhaltsplatzhalter 2">
+            <a:extLst>
+              <a:ext uri="{FF2B5EF4-FFF2-40B4-BE49-F238E27FC236}">
+                <a16:creationId xmlns:a16="http://schemas.microsoft.com/office/drawing/2014/main" id="{6CDCF7A3-AB74-B729-51F7-AFDCE88B0942}"/>
+              </a:ext>
+            </a:extLst>
+          </p:cNvPr>
+          <p:cNvSpPr>
+            <a:spLocks noGrp="1"/>
+          </p:cNvSpPr>
+          <p:nvPr>
+            <p:ph idx="1"/>
+          </p:nvPr>
+        </p:nvSpPr>
+        <p:spPr/>
+        <p:txBody>
+          <a:bodyPr>
+            <a:normAutofit fontScale="62500" lnSpcReduction="20000"/>
+          </a:bodyPr>
+          <a:lstStyle/>
+          <a:p>
+            <a:r>
+              <a:rPr lang="de-DE" b="1" dirty="0"/>
+              <a:t>Im aktuellen Modell wird der physische Verbleib dieses Überschusses nicht ausdrücklich berechnet.</a:t>
+            </a:r>
+            <a:r>
+              <a:rPr lang="de-DE" dirty="0"/>
+              <a:t> Das ist eine wichtige Vereinfachung, die ich im Beispiel deutlicher hätte nennen müssen.</a:t>
+            </a:r>
+          </a:p>
+          <a:p>
+            <a:r>
+              <a:rPr lang="de-DE" dirty="0"/>
+              <a:t>Für die </a:t>
+            </a:r>
+            <a:r>
+              <a:rPr lang="de-DE" b="1" dirty="0"/>
+              <a:t>1.513 MWh Überschuss im Januar</a:t>
+            </a:r>
+            <a:r>
+              <a:rPr lang="de-DE" dirty="0"/>
+              <a:t> gilt:</a:t>
+            </a:r>
+          </a:p>
+          <a:p>
+            <a:pPr lvl="0"/>
+            <a:r>
+              <a:rPr lang="de-DE" dirty="0"/>
+              <a:t>Sie werden als erzeugter erneuerbarer Strom bilanziert.</a:t>
+            </a:r>
+          </a:p>
+          <a:p>
+            <a:pPr lvl="0"/>
+            <a:r>
+              <a:rPr lang="de-DE" dirty="0"/>
+              <a:t>Die H₂-Anlage verbraucht sie nicht direkt.</a:t>
+            </a:r>
+          </a:p>
+          <a:p>
+            <a:pPr lvl="0"/>
+            <a:r>
+              <a:rPr lang="de-DE" dirty="0"/>
+              <a:t>Sie zählen zur monatlichen erneuerbaren Deckung.</a:t>
+            </a:r>
+          </a:p>
+          <a:p>
+            <a:pPr lvl="0"/>
+            <a:r>
+              <a:rPr lang="de-DE" dirty="0"/>
+              <a:t>Das Modell berechnet dafür </a:t>
+            </a:r>
+            <a:r>
+              <a:rPr lang="de-DE" b="1" dirty="0"/>
+              <a:t>keinen konkreten Abnehmer, keine Einspeisegrenze und keinen Verkaufserlös</a:t>
+            </a:r>
+            <a:r>
+              <a:rPr lang="de-DE" dirty="0"/>
+              <a:t>. Eine Stromspeicherung findet ebenfalls nicht statt.</a:t>
+            </a:r>
+          </a:p>
+          <a:p>
+            <a:r>
+              <a:rPr lang="de-DE" b="1" dirty="0"/>
+              <a:t>In einer realen Anlage müsste dieser Strom beispielsweise ins Netz eingespeist oder von einem anderen Verbraucher genutzt werden.</a:t>
+            </a:r>
+            <a:r>
+              <a:rPr lang="de-DE" dirty="0"/>
+              <a:t> Wenn stattdessen die Erzeugung abgeregelt wird, entsteht diese Strommenge nicht und darf auch nicht zur Deckung zählen. Unser Modell führt Abregelung deshalb separat.</a:t>
+            </a:r>
+          </a:p>
+          <a:p>
+            <a:r>
+              <a:rPr lang="de-DE" dirty="0"/>
+              <a:t>Die genaue Antwort lautet also: </a:t>
+            </a:r>
+            <a:r>
+              <a:rPr lang="de-DE" b="1" dirty="0"/>
+              <a:t>Der Überschuss wird derzeit rechnerisch zugeordnet; wohin er tatsächlich fließt, bleibt außerhalb des Modells.</a:t>
+            </a:r>
+            <a:r>
+              <a:rPr lang="de-DE" dirty="0"/>
+              <a:t> Daraus allein lässt sich keine rechtlich zulässige Nutzung nachweisen.</a:t>
+            </a:r>
+          </a:p>
+          <a:p>
+            <a:endParaRPr lang="de-DE" dirty="0"/>
+          </a:p>
+        </p:txBody>
+      </p:sp>
+    </p:spTree>
+    <p:extLst>
+      <p:ext uri="{BB962C8B-B14F-4D97-AF65-F5344CB8AC3E}">
+        <p14:creationId xmlns:p14="http://schemas.microsoft.com/office/powerpoint/2010/main" val="859897302"/>
       </p:ext>
     </p:extLst>
   </p:cSld>

</xml_diff>